<commit_message>
Slides: sd-01-031 PPTX with every line at ten words or fewer
Co-Authored-By: Claude Opus 5.5 <noreply@anthropic.com>
Claude-Session: https://claude.ai/code/session_01PmqNRWe4NoiAuhPfHYj9Qq
</commit_message>
<xml_diff>
--- a/system-design-101/vi/lessons/sd-01-031/slides/sd-01-031.pptx
+++ b/system-design-101/vi/lessons/sd-01-031/slides/sd-01-031.pptx
@@ -11779,7 +11779,7 @@
               <a:t> quả</a:t>
             </a:r>
             <a:r>
-              <a:rPr lang="en-US" sz="2400" dirty="0" spc="-4" kern="0">
+              <a:rPr lang="en-US" sz="2400" dirty="0" spc="0" kern="0">
                 <a:solidFill>
                   <a:srgbClr val="14161C"/>
                 </a:solidFill>
@@ -11787,10 +11787,10 @@
                 <a:ea typeface="Be Vietnam Pro SemiBold" pitchFamily="34" charset="-122"/>
                 <a:cs typeface="Be Vietnam Pro SemiBold" pitchFamily="34" charset="-120"/>
               </a:rPr>
-              <a:t> bằng cơ</a:t>
-            </a:r>
-            <a:r>
-              <a:rPr lang="en-US" sz="2400" dirty="0" spc="-1" kern="0">
+              <a:t> qua</a:t>
+            </a:r>
+            <a:r>
+              <a:rPr lang="en-US" sz="2400" dirty="0" spc="2" kern="0">
                 <a:solidFill>
                   <a:srgbClr val="14161C"/>
                 </a:solidFill>
@@ -11798,10 +11798,10 @@
                 <a:ea typeface="Be Vietnam Pro SemiBold" pitchFamily="34" charset="-122"/>
                 <a:cs typeface="Be Vietnam Pro SemiBold" pitchFamily="34" charset="-120"/>
               </a:rPr>
-              <a:t> chế</a:t>
-            </a:r>
-            <a:r>
-              <a:rPr lang="en-US" sz="2400" dirty="0" spc="1" kern="0">
+              <a:t> dịch</a:t>
+            </a:r>
+            <a:r>
+              <a:rPr lang="en-US" sz="2400" dirty="0" spc="-1" kern="0">
                 <a:solidFill>
                   <a:srgbClr val="14161C"/>
                 </a:solidFill>
@@ -11809,29 +11809,7 @@
                 <a:ea typeface="Be Vietnam Pro SemiBold" pitchFamily="34" charset="-122"/>
                 <a:cs typeface="Be Vietnam Pro SemiBold" pitchFamily="34" charset="-120"/>
               </a:rPr>
-              <a:t> dịch</a:t>
-            </a:r>
-            <a:r>
-              <a:rPr lang="en-US" sz="2400" dirty="0" spc="0" kern="0">
-                <a:solidFill>
-                  <a:srgbClr val="14161C"/>
-                </a:solidFill>
-                <a:latin typeface="Be Vietnam Pro SemiBold" pitchFamily="34" charset="0"/>
-                <a:ea typeface="Be Vietnam Pro SemiBold" pitchFamily="34" charset="-122"/>
-                <a:cs typeface="Be Vietnam Pro SemiBold" pitchFamily="34" charset="-120"/>
-              </a:rPr>
               <a:t> vụ</a:t>
-            </a:r>
-            <a:r>
-              <a:rPr lang="en-US" sz="2400" dirty="0" spc="-1" kern="0">
-                <a:solidFill>
-                  <a:srgbClr val="14161C"/>
-                </a:solidFill>
-                <a:latin typeface="Be Vietnam Pro SemiBold" pitchFamily="34" charset="0"/>
-                <a:ea typeface="Be Vietnam Pro SemiBold" pitchFamily="34" charset="-122"/>
-                <a:cs typeface="Be Vietnam Pro SemiBold" pitchFamily="34" charset="-120"/>
-              </a:rPr>
-              <a:t> cho</a:t>
             </a:r>
             <a:endParaRPr lang="en-US" sz="2400" dirty="0"/>
           </a:p>

</xml_diff>